<commit_message>
docs(press): align pitch deck with the one-pager
Bring deck.pdf/deck.pptx into line with the one-pager, which is the
stronger, more current overview.

- Production URL: raku-api.fly.dev -> rakuai.com (Fly.io is retired; fly.dev refs are a bug per repo rules)
- Endpoints: ~9,700 / 9,481 functions -> 9,500+ API endpoints, 17 native tools (matches one-pager)
- Added 18 native DLLs and 5 patents to the platform stats
- Membership: added AWS Activate alongside NVIDIA Inception
- Added Copilot to the assistant lineup on the title slide
- Added the "glasses render, the phone or edge computes" tagline (slide 7)
- Added vendor-neutral framing (closing slide) and robotics/CV + enterprise (slide 8)
- Removed every em-dash and spaced-hyphen separator from the copy (rewrote sentences)
- Re-exported deck.pdf from the updated deck.pptx

Co-Authored-By: Claude Opus 4.8 (1M context) <noreply@anthropic.com>
</commit_message>
<xml_diff>
--- a/deck.pptx
+++ b/deck.pptx
@@ -2036,7 +2036,7 @@
                 <a:ea typeface="Calibri" pitchFamily="34" charset="-122"/>
                 <a:cs typeface="Calibri" pitchFamily="34" charset="-120"/>
               </a:rPr>
-              <a:t>Claude, ChatGPT, and Gemini can see, measure, and reason about — over MCP.</a:t>
+              <a:t>Claude, ChatGPT, Gemini, and Copilot can see, measure, and reason about, all over MCP.</a:t>
             </a:r>
             <a:endParaRPr lang="en-US" sz="1600" dirty="0"/>
           </a:p>
@@ -2116,7 +2116,7 @@
                 </a:solidFill>
                 <a:latin typeface="Calibri"/>
               </a:rPr>
-              <a:t>NVIDIA Inception Member</a:t>
+              <a:t>NVIDIA Inception Member  ·  AWS Activate</a:t>
             </a:r>
           </a:p>
         </p:txBody>
@@ -3796,7 +3796,7 @@
                 <a:ea typeface="Calibri" pitchFamily="34" charset="-122"/>
                 <a:cs typeface="Calibri" pitchFamily="34" charset="-120"/>
               </a:rPr>
-              <a:t>Spatial AI is happening. RakuAI is the platform that connects every camera to every assistant.</a:t>
+              <a:t>Spatial AI is happening. RakuAI is the vendor-neutral runtime that connects every camera to every assistant.</a:t>
             </a:r>
             <a:endParaRPr lang="en-US" sz="1600" dirty="0"/>
           </a:p>
@@ -3849,7 +3849,7 @@
                 <a:ea typeface="Calibri" pitchFamily="34" charset="-122"/>
                 <a:cs typeface="Calibri" pitchFamily="34" charset="-120"/>
               </a:rPr>
-              <a:t>   ·   </a:t>
+              <a:t xml:space="preserve">   ·   </a:t>
             </a:r>
             <a:pPr indent="0" marL="0">
               <a:buNone/>
@@ -3909,7 +3909,7 @@
                 <a:ea typeface="Calibri" pitchFamily="34" charset="-122"/>
                 <a:cs typeface="Calibri" pitchFamily="34" charset="-120"/>
               </a:rPr>
-              <a:t>   ·   </a:t>
+              <a:t xml:space="preserve">   ·   </a:t>
             </a:r>
             <a:pPr indent="0" marL="0">
               <a:buNone/>
@@ -3937,7 +3937,7 @@
                 <a:ea typeface="Calibri" pitchFamily="34" charset="-122"/>
                 <a:cs typeface="Calibri" pitchFamily="34" charset="-120"/>
               </a:rPr>
-              <a:t>   ·   </a:t>
+              <a:t xml:space="preserve">   ·   </a:t>
             </a:r>
             <a:pPr indent="0" marL="0">
               <a:buNone/>
@@ -4499,7 +4499,7 @@
                 <a:ea typeface="Calibri" pitchFamily="34" charset="-122"/>
                 <a:cs typeface="Calibri" pitchFamily="34" charset="-120"/>
               </a:rPr>
-              <a:t>Today's LLMs can read your code, your email, your data — but they can't see your room.</a:t>
+              <a:t>Today's LLMs can read your code, your email, and your data, yet they can't see your room.</a:t>
             </a:r>
             <a:endParaRPr lang="en-US" sz="1400" dirty="0"/>
           </a:p>
@@ -5271,7 +5271,7 @@
       </p:sp>
       <p:pic>
         <p:nvPicPr>
-          <p:cNvPr id="6" name="Image 0" descr="preencoded.png">    </p:cNvPr>
+          <p:cNvPr id="6" name="Image 0" descr="preencoded.png"/>
           <p:cNvPicPr>
             <a:picLocks noChangeAspect="1"/>
           </p:cNvPicPr>
@@ -5365,7 +5365,7 @@
                 <a:ea typeface="Calibri" pitchFamily="34" charset="-122"/>
                 <a:cs typeface="Calibri" pitchFamily="34" charset="-120"/>
               </a:rPr>
-              <a:t>Guided phone walkthrough captures the space in 30–60 seconds. PWA — installs from any mobile browser, works offline.</a:t>
+              <a:t>Guided phone walkthrough captures the space in 30 to 60 seconds. The PWA installs from any mobile browser and works offline.</a:t>
             </a:r>
             <a:endParaRPr lang="en-US" sz="1150" dirty="0"/>
           </a:p>
@@ -5423,7 +5423,7 @@
       </p:sp>
       <p:pic>
         <p:nvPicPr>
-          <p:cNvPr id="11" name="Image 1" descr="preencoded.png">    </p:cNvPr>
+          <p:cNvPr id="11" name="Image 1" descr="preencoded.png"/>
           <p:cNvPicPr>
             <a:picLocks noChangeAspect="1"/>
           </p:cNvPicPr>
@@ -5575,7 +5575,7 @@
       </p:sp>
       <p:pic>
         <p:nvPicPr>
-          <p:cNvPr id="16" name="Image 2" descr="preencoded.png">    </p:cNvPr>
+          <p:cNvPr id="16" name="Image 2" descr="preencoded.png"/>
           <p:cNvPicPr>
             <a:picLocks noChangeAspect="1"/>
           </p:cNvPicPr>
@@ -5882,7 +5882,7 @@
                 <a:ea typeface="Calibri" pitchFamily="34" charset="-122"/>
                 <a:cs typeface="Calibri" pitchFamily="34" charset="-120"/>
               </a:rPr>
-              <a:t>Production at raku-api.fly.dev. ~9,700 endpoints. C++ engine, Python orchestration, browser PWA.</a:t>
+              <a:t>In production at rakuai.com. 5 patents. 9,500+ API endpoints. C++ engine, Python orchestration, PWA.</a:t>
             </a:r>
             <a:endParaRPr lang="en-US" sz="1400" dirty="0"/>
           </a:p>
@@ -6049,7 +6049,7 @@
                 <a:ea typeface="Calibri" pitchFamily="34" charset="-122"/>
                 <a:cs typeface="Calibri" pitchFamily="34" charset="-120"/>
               </a:rPr>
-              <a:t>C++ spatial engine. Exposes 9,481 functions over MCP. Smart-glasses + Android XR launchable web-app entry.</a:t>
+              <a:t>C++ spatial engine across 18 native DLLs. Exposes thousands of functions over MCP through 17 native tools. Smart-glasses + Android XR launchable web-app entry.</a:t>
             </a:r>
             <a:endParaRPr lang="en-US" sz="1100" dirty="0"/>
           </a:p>
@@ -6177,7 +6177,7 @@
                 <a:ea typeface="Calibri" pitchFamily="34" charset="-122"/>
                 <a:cs typeface="Calibri" pitchFamily="34" charset="-120"/>
               </a:rPr>
-              <a:t>PYTHON BACKEND · ~9,700 ENDPOINTS</a:t>
+              <a:t>PYTHON BACKEND · 9,500+ ENDPOINTS</a:t>
             </a:r>
             <a:endParaRPr lang="en-US" sz="900" dirty="0"/>
           </a:p>
@@ -7314,7 +7314,7 @@
       </p:sp>
       <p:pic>
         <p:nvPicPr>
-          <p:cNvPr id="24" name="Image 0" descr="preencoded.png">    </p:cNvPr>
+          <p:cNvPr id="24" name="Image 0" descr="preencoded.png"/>
           <p:cNvPicPr>
             <a:picLocks noChangeAspect="1"/>
           </p:cNvPicPr>
@@ -7640,7 +7640,7 @@
       </p:sp>
       <p:pic>
         <p:nvPicPr>
-          <p:cNvPr id="6" name="Image 0" descr="preencoded.png">    </p:cNvPr>
+          <p:cNvPr id="6" name="Image 0" descr="preencoded.png"/>
           <p:cNvPicPr>
             <a:picLocks noChangeAspect="1"/>
           </p:cNvPicPr>
@@ -7792,7 +7792,7 @@
       </p:sp>
       <p:pic>
         <p:nvPicPr>
-          <p:cNvPr id="11" name="Image 1" descr="preencoded.png">    </p:cNvPr>
+          <p:cNvPr id="11" name="Image 1" descr="preencoded.png"/>
           <p:cNvPicPr>
             <a:picLocks noChangeAspect="1"/>
           </p:cNvPicPr>
@@ -7944,7 +7944,7 @@
       </p:sp>
       <p:pic>
         <p:nvPicPr>
-          <p:cNvPr id="16" name="Image 2" descr="preencoded.png">    </p:cNvPr>
+          <p:cNvPr id="16" name="Image 2" descr="preencoded.png"/>
           <p:cNvPicPr>
             <a:picLocks noChangeAspect="1"/>
           </p:cNvPicPr>
@@ -8251,7 +8251,7 @@
                 <a:ea typeface="Calibri" pitchFamily="34" charset="-122"/>
                 <a:cs typeface="Calibri" pitchFamily="34" charset="-120"/>
               </a:rPr>
-              <a:t>One capture-app + MCP runtime — three device classes, three LLM assistants.</a:t>
+              <a:t>The glasses render, the phone or edge computes. One runtime, three device classes, every assistant.</a:t>
             </a:r>
             <a:endParaRPr lang="en-US" sz="1400" dirty="0"/>
           </a:p>
@@ -8323,7 +8323,7 @@
       </p:sp>
       <p:pic>
         <p:nvPicPr>
-          <p:cNvPr id="6" name="Image 0" descr="preencoded.png">    </p:cNvPr>
+          <p:cNvPr id="6" name="Image 0" descr="preencoded.png"/>
           <p:cNvPicPr>
             <a:picLocks noChangeAspect="1"/>
           </p:cNvPicPr>
@@ -8450,7 +8450,7 @@
       </p:sp>
       <p:pic>
         <p:nvPicPr>
-          <p:cNvPr id="10" name="Image 1" descr="preencoded.png">    </p:cNvPr>
+          <p:cNvPr id="10" name="Image 1" descr="preencoded.png"/>
           <p:cNvPicPr>
             <a:picLocks noChangeAspect="1"/>
           </p:cNvPicPr>
@@ -8577,7 +8577,7 @@
       </p:sp>
       <p:pic>
         <p:nvPicPr>
-          <p:cNvPr id="14" name="Image 2" descr="preencoded.png">    </p:cNvPr>
+          <p:cNvPr id="14" name="Image 2" descr="preencoded.png"/>
           <p:cNvPicPr>
             <a:picLocks noChangeAspect="1"/>
           </p:cNvPicPr>
@@ -9232,7 +9232,7 @@
                 <a:ea typeface="Calibri" pitchFamily="34" charset="-122"/>
                 <a:cs typeface="Calibri" pitchFamily="34" charset="-120"/>
               </a:rPr>
-              <a:t>Once any room can be queried by an LLM, the use cases stack fast.</a:t>
+              <a:t>Once any room can be queried by an LLM, use cases stack fast, from robotics and CV to enterprise.</a:t>
             </a:r>
             <a:endParaRPr lang="en-US" sz="1400" dirty="0"/>
           </a:p>
@@ -9290,7 +9290,7 @@
       </p:sp>
       <p:pic>
         <p:nvPicPr>
-          <p:cNvPr id="6" name="Image 0" descr="preencoded.png">    </p:cNvPr>
+          <p:cNvPr id="6" name="Image 0" descr="preencoded.png"/>
           <p:cNvPicPr>
             <a:picLocks noChangeAspect="1"/>
           </p:cNvPicPr>
@@ -9442,7 +9442,7 @@
       </p:sp>
       <p:pic>
         <p:nvPicPr>
-          <p:cNvPr id="11" name="Image 1" descr="preencoded.png">    </p:cNvPr>
+          <p:cNvPr id="11" name="Image 1" descr="preencoded.png"/>
           <p:cNvPicPr>
             <a:picLocks noChangeAspect="1"/>
           </p:cNvPicPr>
@@ -9536,7 +9536,7 @@
                 <a:ea typeface="Calibri" pitchFamily="34" charset="-122"/>
                 <a:cs typeface="Calibri" pitchFamily="34" charset="-120"/>
               </a:rPr>
-              <a:t>One-pass scan → itemized contents + measurements. Claims, moves, downsizing — replace a clipboard with a 60-second capture.</a:t>
+              <a:t>One-pass scan → itemized contents + measurements. For claims, moves, and downsizing, it replaces a clipboard with a 60-second capture.</a:t>
             </a:r>
             <a:endParaRPr lang="en-US" sz="1100" dirty="0"/>
           </a:p>
@@ -9594,7 +9594,7 @@
       </p:sp>
       <p:pic>
         <p:nvPicPr>
-          <p:cNvPr id="16" name="Image 2" descr="preencoded.png">    </p:cNvPr>
+          <p:cNvPr id="16" name="Image 2" descr="preencoded.png"/>
           <p:cNvPicPr>
             <a:picLocks noChangeAspect="1"/>
           </p:cNvPicPr>
@@ -9746,7 +9746,7 @@
       </p:sp>
       <p:pic>
         <p:nvPicPr>
-          <p:cNvPr id="21" name="Image 3" descr="preencoded.png">    </p:cNvPr>
+          <p:cNvPr id="21" name="Image 3" descr="preencoded.png"/>
           <p:cNvPicPr>
             <a:picLocks noChangeAspect="1"/>
           </p:cNvPicPr>
@@ -9840,7 +9840,7 @@
                 <a:ea typeface="Calibri" pitchFamily="34" charset="-122"/>
                 <a:cs typeface="Calibri" pitchFamily="34" charset="-120"/>
               </a:rPr>
-              <a:t>Splat assets for game engines, training environments, OpenXR previews — the same pipeline that powers consumer captures.</a:t>
+              <a:t>Splat assets for game engines, training environments, and OpenXR previews, all from the same pipeline that powers consumer captures.</a:t>
             </a:r>
             <a:endParaRPr lang="en-US" sz="1100" dirty="0"/>
           </a:p>
@@ -10061,7 +10061,7 @@
       </p:sp>
       <p:pic>
         <p:nvPicPr>
-          <p:cNvPr id="4" name="Image 0" descr="preencoded.png">    </p:cNvPr>
+          <p:cNvPr id="4" name="Image 0" descr="preencoded.png"/>
           <p:cNvPicPr>
             <a:picLocks noChangeAspect="1"/>
           </p:cNvPicPr>
@@ -10124,7 +10124,7 @@
       </p:sp>
       <p:pic>
         <p:nvPicPr>
-          <p:cNvPr id="6" name="Image 1" descr="preencoded.png">    </p:cNvPr>
+          <p:cNvPr id="6" name="Image 1" descr="preencoded.png"/>
           <p:cNvPicPr>
             <a:picLocks noChangeAspect="1"/>
           </p:cNvPicPr>
@@ -10187,7 +10187,7 @@
       </p:sp>
       <p:pic>
         <p:nvPicPr>
-          <p:cNvPr id="8" name="Image 2" descr="preencoded.png">    </p:cNvPr>
+          <p:cNvPr id="8" name="Image 2" descr="preencoded.png"/>
           <p:cNvPicPr>
             <a:picLocks noChangeAspect="1"/>
           </p:cNvPicPr>
@@ -10242,7 +10242,7 @@
                 <a:ea typeface="Calibri" pitchFamily="34" charset="-122"/>
                 <a:cs typeface="Calibri" pitchFamily="34" charset="-120"/>
               </a:rPr>
-              <a:t>MCP surface  ·  9,481 functions  ·  spatial query layer  ·  reasoning prompt pack</a:t>
+              <a:t>MCP surface  ·  17 native tools  ·  spatial query layer  ·  reasoning prompt pack</a:t>
             </a:r>
             <a:endParaRPr lang="en-US" sz="1200" dirty="0"/>
           </a:p>
@@ -10250,7 +10250,7 @@
       </p:sp>
       <p:pic>
         <p:nvPicPr>
-          <p:cNvPr id="10" name="Image 3" descr="preencoded.png">    </p:cNvPr>
+          <p:cNvPr id="10" name="Image 3" descr="preencoded.png"/>
           <p:cNvPicPr>
             <a:picLocks noChangeAspect="1"/>
           </p:cNvPicPr>
@@ -10313,7 +10313,7 @@
       </p:sp>
       <p:pic>
         <p:nvPicPr>
-          <p:cNvPr id="12" name="Image 4" descr="preencoded.png">    </p:cNvPr>
+          <p:cNvPr id="12" name="Image 4" descr="preencoded.png"/>
           <p:cNvPicPr>
             <a:picLocks noChangeAspect="1"/>
           </p:cNvPicPr>
@@ -10376,7 +10376,7 @@
       </p:sp>
       <p:pic>
         <p:nvPicPr>
-          <p:cNvPr id="14" name="Image 5" descr="preencoded.png">    </p:cNvPr>
+          <p:cNvPr id="14" name="Image 5" descr="preencoded.png"/>
           <p:cNvPicPr>
             <a:picLocks noChangeAspect="1"/>
           </p:cNvPicPr>
@@ -10495,7 +10495,7 @@
                 <a:ea typeface="Calibri" pitchFamily="34" charset="-122"/>
                 <a:cs typeface="Calibri" pitchFamily="34" charset="-120"/>
               </a:rPr>
-              <a:t>Live: </a:t>
+              <a:t xml:space="preserve">Live: </a:t>
             </a:r>
             <a:endParaRPr lang="en-US" sz="1200" dirty="0"/>
           </a:p>

</xml_diff>

<commit_message>
docs(press): align pitch deck with the one-pager (#415)
Bring deck.pdf/deck.pptx into line with the one-pager, which is the
stronger, more current overview.

- Production URL: raku-api.fly.dev -> rakuai.com (Fly.io is retired; fly.dev refs are a bug per repo rules)
- Endpoints: ~9,700 / 9,481 functions -> 9,500+ API endpoints, 17 native tools (matches one-pager)
- Added 18 native DLLs and 5 patents to the platform stats
- Membership: added AWS Activate alongside NVIDIA Inception
- Added Copilot to the assistant lineup on the title slide
- Added the "glasses render, the phone or edge computes" tagline (slide 7)
- Added vendor-neutral framing (closing slide) and robotics/CV + enterprise (slide 8)
- Removed every em-dash and spaced-hyphen separator from the copy (rewrote sentences)
- Re-exported deck.pdf from the updated deck.pptx

Co-authored-by: Claude Opus 4.8 (1M context) <noreply@anthropic.com>
</commit_message>
<xml_diff>
--- a/deck.pptx
+++ b/deck.pptx
@@ -2036,7 +2036,7 @@
                 <a:ea typeface="Calibri" pitchFamily="34" charset="-122"/>
                 <a:cs typeface="Calibri" pitchFamily="34" charset="-120"/>
               </a:rPr>
-              <a:t>Claude, ChatGPT, and Gemini can see, measure, and reason about — over MCP.</a:t>
+              <a:t>Claude, ChatGPT, Gemini, and Copilot can see, measure, and reason about, all over MCP.</a:t>
             </a:r>
             <a:endParaRPr lang="en-US" sz="1600" dirty="0"/>
           </a:p>
@@ -2116,7 +2116,7 @@
                 </a:solidFill>
                 <a:latin typeface="Calibri"/>
               </a:rPr>
-              <a:t>NVIDIA Inception Member</a:t>
+              <a:t>NVIDIA Inception Member  ·  AWS Activate</a:t>
             </a:r>
           </a:p>
         </p:txBody>
@@ -3796,7 +3796,7 @@
                 <a:ea typeface="Calibri" pitchFamily="34" charset="-122"/>
                 <a:cs typeface="Calibri" pitchFamily="34" charset="-120"/>
               </a:rPr>
-              <a:t>Spatial AI is happening. RakuAI is the platform that connects every camera to every assistant.</a:t>
+              <a:t>Spatial AI is happening. RakuAI is the vendor-neutral runtime that connects every camera to every assistant.</a:t>
             </a:r>
             <a:endParaRPr lang="en-US" sz="1600" dirty="0"/>
           </a:p>
@@ -3849,7 +3849,7 @@
                 <a:ea typeface="Calibri" pitchFamily="34" charset="-122"/>
                 <a:cs typeface="Calibri" pitchFamily="34" charset="-120"/>
               </a:rPr>
-              <a:t>   ·   </a:t>
+              <a:t xml:space="preserve">   ·   </a:t>
             </a:r>
             <a:pPr indent="0" marL="0">
               <a:buNone/>
@@ -3909,7 +3909,7 @@
                 <a:ea typeface="Calibri" pitchFamily="34" charset="-122"/>
                 <a:cs typeface="Calibri" pitchFamily="34" charset="-120"/>
               </a:rPr>
-              <a:t>   ·   </a:t>
+              <a:t xml:space="preserve">   ·   </a:t>
             </a:r>
             <a:pPr indent="0" marL="0">
               <a:buNone/>
@@ -3937,7 +3937,7 @@
                 <a:ea typeface="Calibri" pitchFamily="34" charset="-122"/>
                 <a:cs typeface="Calibri" pitchFamily="34" charset="-120"/>
               </a:rPr>
-              <a:t>   ·   </a:t>
+              <a:t xml:space="preserve">   ·   </a:t>
             </a:r>
             <a:pPr indent="0" marL="0">
               <a:buNone/>
@@ -4499,7 +4499,7 @@
                 <a:ea typeface="Calibri" pitchFamily="34" charset="-122"/>
                 <a:cs typeface="Calibri" pitchFamily="34" charset="-120"/>
               </a:rPr>
-              <a:t>Today's LLMs can read your code, your email, your data — but they can't see your room.</a:t>
+              <a:t>Today's LLMs can read your code, your email, and your data, yet they can't see your room.</a:t>
             </a:r>
             <a:endParaRPr lang="en-US" sz="1400" dirty="0"/>
           </a:p>
@@ -5271,7 +5271,7 @@
       </p:sp>
       <p:pic>
         <p:nvPicPr>
-          <p:cNvPr id="6" name="Image 0" descr="preencoded.png">    </p:cNvPr>
+          <p:cNvPr id="6" name="Image 0" descr="preencoded.png"/>
           <p:cNvPicPr>
             <a:picLocks noChangeAspect="1"/>
           </p:cNvPicPr>
@@ -5365,7 +5365,7 @@
                 <a:ea typeface="Calibri" pitchFamily="34" charset="-122"/>
                 <a:cs typeface="Calibri" pitchFamily="34" charset="-120"/>
               </a:rPr>
-              <a:t>Guided phone walkthrough captures the space in 30–60 seconds. PWA — installs from any mobile browser, works offline.</a:t>
+              <a:t>Guided phone walkthrough captures the space in 30 to 60 seconds. The PWA installs from any mobile browser and works offline.</a:t>
             </a:r>
             <a:endParaRPr lang="en-US" sz="1150" dirty="0"/>
           </a:p>
@@ -5423,7 +5423,7 @@
       </p:sp>
       <p:pic>
         <p:nvPicPr>
-          <p:cNvPr id="11" name="Image 1" descr="preencoded.png">    </p:cNvPr>
+          <p:cNvPr id="11" name="Image 1" descr="preencoded.png"/>
           <p:cNvPicPr>
             <a:picLocks noChangeAspect="1"/>
           </p:cNvPicPr>
@@ -5575,7 +5575,7 @@
       </p:sp>
       <p:pic>
         <p:nvPicPr>
-          <p:cNvPr id="16" name="Image 2" descr="preencoded.png">    </p:cNvPr>
+          <p:cNvPr id="16" name="Image 2" descr="preencoded.png"/>
           <p:cNvPicPr>
             <a:picLocks noChangeAspect="1"/>
           </p:cNvPicPr>
@@ -5882,7 +5882,7 @@
                 <a:ea typeface="Calibri" pitchFamily="34" charset="-122"/>
                 <a:cs typeface="Calibri" pitchFamily="34" charset="-120"/>
               </a:rPr>
-              <a:t>Production at raku-api.fly.dev. ~9,700 endpoints. C++ engine, Python orchestration, browser PWA.</a:t>
+              <a:t>In production at rakuai.com. 5 patents. 9,500+ API endpoints. C++ engine, Python orchestration, PWA.</a:t>
             </a:r>
             <a:endParaRPr lang="en-US" sz="1400" dirty="0"/>
           </a:p>
@@ -6049,7 +6049,7 @@
                 <a:ea typeface="Calibri" pitchFamily="34" charset="-122"/>
                 <a:cs typeface="Calibri" pitchFamily="34" charset="-120"/>
               </a:rPr>
-              <a:t>C++ spatial engine. Exposes 9,481 functions over MCP. Smart-glasses + Android XR launchable web-app entry.</a:t>
+              <a:t>C++ spatial engine across 18 native DLLs. Exposes thousands of functions over MCP through 17 native tools. Smart-glasses + Android XR launchable web-app entry.</a:t>
             </a:r>
             <a:endParaRPr lang="en-US" sz="1100" dirty="0"/>
           </a:p>
@@ -6177,7 +6177,7 @@
                 <a:ea typeface="Calibri" pitchFamily="34" charset="-122"/>
                 <a:cs typeface="Calibri" pitchFamily="34" charset="-120"/>
               </a:rPr>
-              <a:t>PYTHON BACKEND · ~9,700 ENDPOINTS</a:t>
+              <a:t>PYTHON BACKEND · 9,500+ ENDPOINTS</a:t>
             </a:r>
             <a:endParaRPr lang="en-US" sz="900" dirty="0"/>
           </a:p>
@@ -7314,7 +7314,7 @@
       </p:sp>
       <p:pic>
         <p:nvPicPr>
-          <p:cNvPr id="24" name="Image 0" descr="preencoded.png">    </p:cNvPr>
+          <p:cNvPr id="24" name="Image 0" descr="preencoded.png"/>
           <p:cNvPicPr>
             <a:picLocks noChangeAspect="1"/>
           </p:cNvPicPr>
@@ -7640,7 +7640,7 @@
       </p:sp>
       <p:pic>
         <p:nvPicPr>
-          <p:cNvPr id="6" name="Image 0" descr="preencoded.png">    </p:cNvPr>
+          <p:cNvPr id="6" name="Image 0" descr="preencoded.png"/>
           <p:cNvPicPr>
             <a:picLocks noChangeAspect="1"/>
           </p:cNvPicPr>
@@ -7792,7 +7792,7 @@
       </p:sp>
       <p:pic>
         <p:nvPicPr>
-          <p:cNvPr id="11" name="Image 1" descr="preencoded.png">    </p:cNvPr>
+          <p:cNvPr id="11" name="Image 1" descr="preencoded.png"/>
           <p:cNvPicPr>
             <a:picLocks noChangeAspect="1"/>
           </p:cNvPicPr>
@@ -7944,7 +7944,7 @@
       </p:sp>
       <p:pic>
         <p:nvPicPr>
-          <p:cNvPr id="16" name="Image 2" descr="preencoded.png">    </p:cNvPr>
+          <p:cNvPr id="16" name="Image 2" descr="preencoded.png"/>
           <p:cNvPicPr>
             <a:picLocks noChangeAspect="1"/>
           </p:cNvPicPr>
@@ -8251,7 +8251,7 @@
                 <a:ea typeface="Calibri" pitchFamily="34" charset="-122"/>
                 <a:cs typeface="Calibri" pitchFamily="34" charset="-120"/>
               </a:rPr>
-              <a:t>One capture-app + MCP runtime — three device classes, three LLM assistants.</a:t>
+              <a:t>The glasses render, the phone or edge computes. One runtime, three device classes, every assistant.</a:t>
             </a:r>
             <a:endParaRPr lang="en-US" sz="1400" dirty="0"/>
           </a:p>
@@ -8323,7 +8323,7 @@
       </p:sp>
       <p:pic>
         <p:nvPicPr>
-          <p:cNvPr id="6" name="Image 0" descr="preencoded.png">    </p:cNvPr>
+          <p:cNvPr id="6" name="Image 0" descr="preencoded.png"/>
           <p:cNvPicPr>
             <a:picLocks noChangeAspect="1"/>
           </p:cNvPicPr>
@@ -8450,7 +8450,7 @@
       </p:sp>
       <p:pic>
         <p:nvPicPr>
-          <p:cNvPr id="10" name="Image 1" descr="preencoded.png">    </p:cNvPr>
+          <p:cNvPr id="10" name="Image 1" descr="preencoded.png"/>
           <p:cNvPicPr>
             <a:picLocks noChangeAspect="1"/>
           </p:cNvPicPr>
@@ -8577,7 +8577,7 @@
       </p:sp>
       <p:pic>
         <p:nvPicPr>
-          <p:cNvPr id="14" name="Image 2" descr="preencoded.png">    </p:cNvPr>
+          <p:cNvPr id="14" name="Image 2" descr="preencoded.png"/>
           <p:cNvPicPr>
             <a:picLocks noChangeAspect="1"/>
           </p:cNvPicPr>
@@ -9232,7 +9232,7 @@
                 <a:ea typeface="Calibri" pitchFamily="34" charset="-122"/>
                 <a:cs typeface="Calibri" pitchFamily="34" charset="-120"/>
               </a:rPr>
-              <a:t>Once any room can be queried by an LLM, the use cases stack fast.</a:t>
+              <a:t>Once any room can be queried by an LLM, use cases stack fast, from robotics and CV to enterprise.</a:t>
             </a:r>
             <a:endParaRPr lang="en-US" sz="1400" dirty="0"/>
           </a:p>
@@ -9290,7 +9290,7 @@
       </p:sp>
       <p:pic>
         <p:nvPicPr>
-          <p:cNvPr id="6" name="Image 0" descr="preencoded.png">    </p:cNvPr>
+          <p:cNvPr id="6" name="Image 0" descr="preencoded.png"/>
           <p:cNvPicPr>
             <a:picLocks noChangeAspect="1"/>
           </p:cNvPicPr>
@@ -9442,7 +9442,7 @@
       </p:sp>
       <p:pic>
         <p:nvPicPr>
-          <p:cNvPr id="11" name="Image 1" descr="preencoded.png">    </p:cNvPr>
+          <p:cNvPr id="11" name="Image 1" descr="preencoded.png"/>
           <p:cNvPicPr>
             <a:picLocks noChangeAspect="1"/>
           </p:cNvPicPr>
@@ -9536,7 +9536,7 @@
                 <a:ea typeface="Calibri" pitchFamily="34" charset="-122"/>
                 <a:cs typeface="Calibri" pitchFamily="34" charset="-120"/>
               </a:rPr>
-              <a:t>One-pass scan → itemized contents + measurements. Claims, moves, downsizing — replace a clipboard with a 60-second capture.</a:t>
+              <a:t>One-pass scan → itemized contents + measurements. For claims, moves, and downsizing, it replaces a clipboard with a 60-second capture.</a:t>
             </a:r>
             <a:endParaRPr lang="en-US" sz="1100" dirty="0"/>
           </a:p>
@@ -9594,7 +9594,7 @@
       </p:sp>
       <p:pic>
         <p:nvPicPr>
-          <p:cNvPr id="16" name="Image 2" descr="preencoded.png">    </p:cNvPr>
+          <p:cNvPr id="16" name="Image 2" descr="preencoded.png"/>
           <p:cNvPicPr>
             <a:picLocks noChangeAspect="1"/>
           </p:cNvPicPr>
@@ -9746,7 +9746,7 @@
       </p:sp>
       <p:pic>
         <p:nvPicPr>
-          <p:cNvPr id="21" name="Image 3" descr="preencoded.png">    </p:cNvPr>
+          <p:cNvPr id="21" name="Image 3" descr="preencoded.png"/>
           <p:cNvPicPr>
             <a:picLocks noChangeAspect="1"/>
           </p:cNvPicPr>
@@ -9840,7 +9840,7 @@
                 <a:ea typeface="Calibri" pitchFamily="34" charset="-122"/>
                 <a:cs typeface="Calibri" pitchFamily="34" charset="-120"/>
               </a:rPr>
-              <a:t>Splat assets for game engines, training environments, OpenXR previews — the same pipeline that powers consumer captures.</a:t>
+              <a:t>Splat assets for game engines, training environments, and OpenXR previews, all from the same pipeline that powers consumer captures.</a:t>
             </a:r>
             <a:endParaRPr lang="en-US" sz="1100" dirty="0"/>
           </a:p>
@@ -10061,7 +10061,7 @@
       </p:sp>
       <p:pic>
         <p:nvPicPr>
-          <p:cNvPr id="4" name="Image 0" descr="preencoded.png">    </p:cNvPr>
+          <p:cNvPr id="4" name="Image 0" descr="preencoded.png"/>
           <p:cNvPicPr>
             <a:picLocks noChangeAspect="1"/>
           </p:cNvPicPr>
@@ -10124,7 +10124,7 @@
       </p:sp>
       <p:pic>
         <p:nvPicPr>
-          <p:cNvPr id="6" name="Image 1" descr="preencoded.png">    </p:cNvPr>
+          <p:cNvPr id="6" name="Image 1" descr="preencoded.png"/>
           <p:cNvPicPr>
             <a:picLocks noChangeAspect="1"/>
           </p:cNvPicPr>
@@ -10187,7 +10187,7 @@
       </p:sp>
       <p:pic>
         <p:nvPicPr>
-          <p:cNvPr id="8" name="Image 2" descr="preencoded.png">    </p:cNvPr>
+          <p:cNvPr id="8" name="Image 2" descr="preencoded.png"/>
           <p:cNvPicPr>
             <a:picLocks noChangeAspect="1"/>
           </p:cNvPicPr>
@@ -10242,7 +10242,7 @@
                 <a:ea typeface="Calibri" pitchFamily="34" charset="-122"/>
                 <a:cs typeface="Calibri" pitchFamily="34" charset="-120"/>
               </a:rPr>
-              <a:t>MCP surface  ·  9,481 functions  ·  spatial query layer  ·  reasoning prompt pack</a:t>
+              <a:t>MCP surface  ·  17 native tools  ·  spatial query layer  ·  reasoning prompt pack</a:t>
             </a:r>
             <a:endParaRPr lang="en-US" sz="1200" dirty="0"/>
           </a:p>
@@ -10250,7 +10250,7 @@
       </p:sp>
       <p:pic>
         <p:nvPicPr>
-          <p:cNvPr id="10" name="Image 3" descr="preencoded.png">    </p:cNvPr>
+          <p:cNvPr id="10" name="Image 3" descr="preencoded.png"/>
           <p:cNvPicPr>
             <a:picLocks noChangeAspect="1"/>
           </p:cNvPicPr>
@@ -10313,7 +10313,7 @@
       </p:sp>
       <p:pic>
         <p:nvPicPr>
-          <p:cNvPr id="12" name="Image 4" descr="preencoded.png">    </p:cNvPr>
+          <p:cNvPr id="12" name="Image 4" descr="preencoded.png"/>
           <p:cNvPicPr>
             <a:picLocks noChangeAspect="1"/>
           </p:cNvPicPr>
@@ -10376,7 +10376,7 @@
       </p:sp>
       <p:pic>
         <p:nvPicPr>
-          <p:cNvPr id="14" name="Image 5" descr="preencoded.png">    </p:cNvPr>
+          <p:cNvPr id="14" name="Image 5" descr="preencoded.png"/>
           <p:cNvPicPr>
             <a:picLocks noChangeAspect="1"/>
           </p:cNvPicPr>
@@ -10495,7 +10495,7 @@
                 <a:ea typeface="Calibri" pitchFamily="34" charset="-122"/>
                 <a:cs typeface="Calibri" pitchFamily="34" charset="-120"/>
               </a:rPr>
-              <a:t>Live: </a:t>
+              <a:t xml:space="preserve">Live: </a:t>
             </a:r>
             <a:endParaRPr lang="en-US" sz="1200" dirty="0"/>
           </a:p>

</xml_diff>